<commit_message>
Add end-to-end workflow diagram to slide 4
Slide 4's first bullet claims "scan -> redact -> send -> decide ->
execute" but had no visual for it - the two existing diagrams (slide 2's
on-device detection pipeline, slide 3's component architecture) cover
different, more technical angles. Added a dedicated 5-step workflow
diagram (Scan/Redact/Send/Decide/Execute) in the slide's empty bottom
space.

Trimmed the Roadmap bullet's wording slightly (dropped the parenthetical
already covered by the Challenges bullet above it) and reduced body text
from 15pt to 12.5pt to free enough vertical room for the diagram without
overlap - verified by rendering the slide via PowerPoint COM automation
before and after.

Co-Authored-By: Claude Sonnet 5 <noreply@anthropic.com>
</commit_message>
<xml_diff>
--- a/Final SIH 2026 (1).pptx
+++ b/Final SIH 2026 (1).pptx
@@ -7356,7 +7356,7 @@
               </a:spcAft>
             </a:pPr>
             <a:r>
-              <a:rPr sz="1500" b="0" dirty="0">
+              <a:rPr sz="1250" b="0" dirty="0">
                 <a:latin typeface="+mn-lt"/>
               </a:rPr>
               <a:t>• Fully working prototype already built and tested end-to-end (scan → redact → send → decide → execute) on a real demo form</a:t>
@@ -7369,19 +7369,19 @@
               </a:spcAft>
             </a:pPr>
             <a:r>
-              <a:rPr sz="1500" b="0" dirty="0">
+              <a:rPr sz="1250" b="0" dirty="0">
                 <a:latin typeface="+mn-lt"/>
               </a:rPr>
               <a:t>• No heavy infrastructure needed — runs entirely on </a:t>
             </a:r>
             <a:r>
-              <a:rPr sz="1500" b="0" dirty="0" err="1">
+              <a:rPr sz="1250" b="0" dirty="0" err="1">
                 <a:latin typeface="+mn-lt"/>
               </a:rPr>
               <a:t>localhost</a:t>
             </a:r>
             <a:r>
-              <a:rPr sz="1500" b="0" dirty="0">
+              <a:rPr sz="1250" b="0" dirty="0">
                 <a:latin typeface="+mn-lt"/>
               </a:rPr>
               <a:t>, no cloud costs, no GPU required</a:t>
@@ -7394,19 +7394,19 @@
               </a:spcAft>
             </a:pPr>
             <a:r>
-              <a:rPr sz="1500" b="0" dirty="0">
+              <a:rPr sz="1250" b="0" dirty="0">
                 <a:latin typeface="+mn-lt"/>
               </a:rPr>
               <a:t>• Uses only mature, well-supported tech (Chrome Extensions API, </a:t>
             </a:r>
             <a:r>
-              <a:rPr sz="1500" b="0" dirty="0" err="1">
+              <a:rPr sz="1250" b="0" dirty="0" err="1">
                 <a:latin typeface="+mn-lt"/>
               </a:rPr>
               <a:t>FastAPI</a:t>
             </a:r>
             <a:r>
-              <a:rPr sz="1500" b="0" dirty="0">
+              <a:rPr sz="1250" b="0" dirty="0">
                 <a:latin typeface="+mn-lt"/>
               </a:rPr>
               <a:t>, optional local LLM runtimes)</a:t>
@@ -7432,7 +7432,7 @@
               </a:spcAft>
             </a:pPr>
             <a:r>
-              <a:rPr sz="1500" b="0" dirty="0">
+              <a:rPr sz="1250" b="0" dirty="0">
                 <a:latin typeface="+mn-lt"/>
               </a:rPr>
               <a:t>• Name/address detection is label-based heuristic, not true NER — may miss unlabeled free-text PII</a:t>
@@ -7445,19 +7445,19 @@
               </a:spcAft>
             </a:pPr>
             <a:r>
-              <a:rPr sz="1500" b="0" dirty="0">
+              <a:rPr sz="1250" b="0" dirty="0">
                 <a:latin typeface="+mn-lt"/>
               </a:rPr>
               <a:t>• Small local LLMs (0.5B–1B </a:t>
             </a:r>
             <a:r>
-              <a:rPr sz="1500" b="0" dirty="0" err="1">
+              <a:rPr sz="1250" b="0" dirty="0" err="1">
                 <a:latin typeface="+mn-lt"/>
               </a:rPr>
               <a:t>params</a:t>
             </a:r>
             <a:r>
-              <a:rPr sz="1500" b="0" dirty="0">
+              <a:rPr sz="1250" b="0" dirty="0">
                 <a:latin typeface="+mn-lt"/>
               </a:rPr>
               <a:t>) can be slow or occasionally produce malformed output</a:t>
@@ -7470,19 +7470,19 @@
               </a:spcAft>
             </a:pPr>
             <a:r>
-              <a:rPr sz="1500" b="0" dirty="0">
+              <a:rPr sz="1250" b="0" dirty="0">
                 <a:latin typeface="+mn-lt"/>
               </a:rPr>
               <a:t>• Pattern-based PII checks (</a:t>
             </a:r>
             <a:r>
-              <a:rPr sz="1500" b="0" dirty="0" err="1">
+              <a:rPr sz="1250" b="0" dirty="0" err="1">
                 <a:latin typeface="+mn-lt"/>
               </a:rPr>
               <a:t>Aadhaar</a:t>
             </a:r>
             <a:r>
-              <a:rPr sz="1500" b="0" dirty="0">
+              <a:rPr sz="1250" b="0" dirty="0">
                 <a:latin typeface="+mn-lt"/>
               </a:rPr>
               <a:t>/PAN/card) are shape-based, not checksum-validated</a:t>
@@ -7495,7 +7495,7 @@
               </a:spcAft>
             </a:pPr>
             <a:r>
-              <a:rPr sz="1500" b="0" dirty="0">
+              <a:rPr sz="1250" b="0" dirty="0">
                 <a:latin typeface="+mn-lt"/>
               </a:rPr>
               <a:t>• No authentication on the local server (acceptable for a local prototype, would need hardening for production)</a:t>
@@ -7521,7 +7521,7 @@
               </a:spcAft>
             </a:pPr>
             <a:r>
-              <a:rPr sz="1500" b="0" dirty="0">
+              <a:rPr sz="1250" b="0" dirty="0">
                 <a:latin typeface="+mn-lt"/>
               </a:rPr>
               <a:t>• Rule-based fallback guarantees the agent never breaks even if the LLM fails or is absent</a:t>
@@ -7534,7 +7534,7 @@
               </a:spcAft>
             </a:pPr>
             <a:r>
-              <a:rPr sz="1500" b="0" dirty="0">
+              <a:rPr sz="1250" b="0" dirty="0">
                 <a:latin typeface="+mn-lt"/>
               </a:rPr>
               <a:t>• Server-side re-validation (defense-in-depth) catches any client-side redaction gaps</a:t>
@@ -7547,10 +7547,10 @@
               </a:spcAft>
             </a:pPr>
             <a:r>
-              <a:rPr sz="1500" b="0" dirty="0">
+              <a:rPr sz="1250" b="0" dirty="0">
                 <a:latin typeface="+mn-lt"/>
               </a:rPr>
-              <a:t>• Roadmap: upgrade on-device perception from structural DOM analysis to a lightweight local vision model (e.g. a small ViT) for pixel-level screen understanding, plus real NER for name/address, checksum validation (Luhn, Aadhaar Verhoeff), and auth for non-local deployment</a:t>
+              <a:t>• Roadmap: upgrade to a lightweight local vision model for pixel-level screen understanding, plus real NER, checksum validation, and auth for non-local deployment</a:t>
             </a:r>
           </a:p>
         </p:txBody>
@@ -7784,6 +7784,30 @@
           <a:xfrm>
             <a:off x="9780086" y="1500"/>
             <a:ext cx="2249850" cy="1062337"/>
+          </a:xfrm>
+          <a:prstGeom prst="rect">
+            <a:avLst/>
+          </a:prstGeom>
+        </p:spPr>
+      </p:pic>
+      <p:pic>
+        <p:nvPicPr>
+          <p:cNvPr id="17411" name="Picture 17410" descr="image.png"/>
+          <p:cNvPicPr>
+            <a:picLocks noChangeAspect="1"/>
+          </p:cNvPicPr>
+          <p:nvPr/>
+        </p:nvPicPr>
+        <p:blipFill>
+          <a:blip r:embed="rId4"/>
+          <a:stretch>
+            <a:fillRect/>
+          </a:stretch>
+        </p:blipFill>
+        <p:spPr>
+          <a:xfrm>
+            <a:off x="4102250" y="5450000"/>
+            <a:ext cx="3987499" cy="870000"/>
           </a:xfrm>
           <a:prstGeom prst="rect">
             <a:avLst/>

</xml_diff>